<commit_message>
docs: refine presentation rotation matrix and slide notes
</commit_message>
<xml_diff>
--- a/docs/sprint1/EDUPORTAL_Sprint1_Presentation.pptx
+++ b/docs/sprint1/EDUPORTAL_Sprint1_Presentation.pptx
@@ -520,17 +520,17 @@
           </a:p>
           <a:p>
             <a:r>
-              <a:t>1. Вітання комісії/викладачу. Представлення команди EduGuard та продукту №6 «ЕдуПортал» (система дистанційного навчання).</a:t>
-            </a:r>
-          </a:p>
-          <a:p>
-            <a:r>
-              <a:t>2. Мета Спринта 1: закласти якісну інженерну основу — сформувати профіль продукту, змоделювати бізнес-процеси за стандартом BPMN 2.0, формалізувати User Stories із критеріями прийняття та налаштувати командний процес.</a:t>
-            </a:r>
-          </a:p>
-          <a:p>
-            <a:r>
-              <a:t>3. Розподіл ролей: Денис — Керівник тестування і Скрам-майстер, Олександр — Інженер з тестування, Володимир — Тест-аналітик.</a:t>
+              <a:t>1. Вітання викладачу та опонентам. Представлення команди EduGuard та продукту №6 «ЕдуПортал» (LMS-система).</a:t>
+            </a:r>
+          </a:p>
+          <a:p>
+            <a:r>
+              <a:t>2. Мета Спринта 1: закласти якісний фундамент — профіль продукту, BPMN 2.0 моделі, беклог вимог із критеріями прийняття та налаштувати командний процес.</a:t>
+            </a:r>
+          </a:p>
+          <a:p>
+            <a:r>
+              <a:t>3. Розподіл ролей у Спринті 1: Денис — КТ+СМ, Олександр — ІТ, Володимир — ТА.</a:t>
             </a:r>
           </a:p>
         </p:txBody>
@@ -610,17 +610,17 @@
           </a:p>
           <a:p>
             <a:r>
-              <a:t>1. «ЕдуПортал» — це повнофункціональна навчальна платформа. Основний фокус нашої команди тестування — надійність алгоритмів оцінювання, стабільність роботи під час пікових навантажень тестування та зручність взаємодії викладача і студента.</a:t>
-            </a:r>
-          </a:p>
-          <a:p>
-            <a:r>
-              <a:t>2. У Статуті команди ми зафіксували прозорі правила: щоденна комунікація, крос-рев'ю кожного документу і суворе дотримання Definition of Done.</a:t>
-            </a:r>
-          </a:p>
-          <a:p>
-            <a:r>
-              <a:t>3. Матриця ротації забезпечує, що кожен член команди спробує себе у всіх інженерних ролях протягом 5 спринтів.</a:t>
+              <a:t>1. «ЕдуПортал» — масштабована навчальна платформа з 4 рольовими групами.</a:t>
+            </a:r>
+          </a:p>
+          <a:p>
+            <a:r>
+              <a:t>2. У Статуті команди зафіксовано правила: щоденні стендапи, крос-рев'ю та Definition of Done.</a:t>
+            </a:r>
+          </a:p>
+          <a:p>
+            <a:r>
+              <a:t>3. Відповідно до вимог курсу (§5.2), ми заздалегідь спланували матрицю ротації на всі 5 спринтів, де обов'язки КТ+СМ, ІТ та ТА циклічно переходять між Денисом, Олександром та Володимиром.</a:t>
             </a:r>
           </a:p>
         </p:txBody>
@@ -700,17 +700,17 @@
           </a:p>
           <a:p>
             <a:r>
-              <a:t>1. Для системи «ЕдуПортал» ми виділили 4 ключові бізнес-процеси, які покривають 100% життєвого циклу користувача.</a:t>
-            </a:r>
-          </a:p>
-          <a:p>
-            <a:r>
-              <a:t>2. Перші два процеси (Авторизація та Подання завдань) детально описані в специфікації product.md.</a:t>
-            </a:r>
-          </a:p>
-          <a:p>
-            <a:r>
-              <a:t>3. Два найбільш критичні інженерні процеси — «Проходження тестування» та «Створення курсу» — були повністю формалізовані та змодельовані за міжнародним стандартом BPMN 2.0.</a:t>
+              <a:t>1. Для системи «ЕдуПортал» ми виділили 4 наскрізні процеси, що охоплюють увесь життєвий цикл навчання.</a:t>
+            </a:r>
+          </a:p>
+          <a:p>
+            <a:r>
+              <a:t>2. Процеси 1 та 2 описані у специфікації product.md.</a:t>
+            </a:r>
+          </a:p>
+          <a:p>
+            <a:r>
+              <a:t>3. Процеси 3 та 4 (Тестування та Створення курсу) детально змодельовані у форматі BPMN 2.0 та перевірені за 10-пунктовим інженерним чек-листом.</a:t>
             </a:r>
           </a:p>
         </p:txBody>
@@ -790,22 +790,22 @@
           </a:p>
           <a:p>
             <a:r>
-              <a:t>1. У моделі тестування 01_testing.bpmn ми суворо дотрималися нотації BPMN 2.0. Тут реалізовано взаємодію двох автономних учасників: користувача-студента та бекенду LMS.</a:t>
-            </a:r>
-          </a:p>
-          <a:p>
-            <a:r>
-              <a:t>2. Зверніть увагу на розгорнутий підпроцес опрацювання питань, який інкапсулює циклічну роботу студента.</a:t>
-            </a:r>
-          </a:p>
-          <a:p>
-            <a:r>
-              <a:t>3. Важливий інженерний аспект: використання Event-Based Gateway. Тест завершується або за таймером, або за ручною відправкою — обидві події коректно перехоплюються через Intermediate Catch Events.</a:t>
-            </a:r>
-          </a:p>
-          <a:p>
-            <a:r>
-              <a:t>4. Файл повністю перевірено в онлайн-інструменті bpmn.io, жодних синтаксичних чи графічних помилок немає.</a:t>
+              <a:t>1. У моделі тестування 01_testing.bpmn реалізовано взаємодію двох учасників: студента та LMS-серверу через 5 інформаційних потоків повідомлень.</a:t>
+            </a:r>
+          </a:p>
+          <a:p>
+            <a:r>
+              <a:t>2. Циклічну роботу студента оформлено як розгорнутий підпроцес.</a:t>
+            </a:r>
+          </a:p>
+          <a:p>
+            <a:r>
+              <a:t>3. Контроль дедлайну спроби реалізовано через Event-Based Gateway: система однаково коректно обробляє як ручне завершення, так і спрацювання таймера.</a:t>
+            </a:r>
+          </a:p>
+          <a:p>
+            <a:r>
+              <a:t>4. Діаграма повністю сумісна з bpmn.io.</a:t>
             </a:r>
           </a:p>
         </p:txBody>
@@ -885,17 +885,17 @@
           </a:p>
           <a:p>
             <a:r>
-              <a:t>1. У моделі 02_course_creation.bpmn ми вирішили складну інженерну проблему — коректну обробку циклів повернення на доопрацювання при наявності паралельних гілок.</a:t>
-            </a:r>
-          </a:p>
-          <a:p>
-            <a:r>
-              <a:t>2. Якщо повернути потік безпосередньо в паралельний шлюз AND, виникає дедлок або генерація зайвих токенів. Ми вирішили це за класичним патерном: поставили синхронізуючий XOR Merge перед AND Fork.</a:t>
-            </a:r>
-          </a:p>
-          <a:p>
-            <a:r>
-              <a:t>3. Модель демонструє повний цикл від отримання заявки до публікації в каталозі LMS.</a:t>
+              <a:t>1. У моделі створення курсу 02_course_creation.bpmn реалізовано розгалуження на 4 паралельні потоки (AND Fork).</a:t>
+            </a:r>
+          </a:p>
+          <a:p>
+            <a:r>
+              <a:t>2. Особливий акцент — безпека потоків: петля повернення після аудиту входить у спеціальний XOR Merge перед паралельним шлюзом, що запобігає блокуванню процесу (deadlock-free).</a:t>
+            </a:r>
+          </a:p>
+          <a:p>
+            <a:r>
+              <a:t>3. Тільки після затвердження менеджером курс автоматично публікується в LMS.</a:t>
             </a:r>
           </a:p>
         </p:txBody>
@@ -975,22 +975,17 @@
           </a:p>
           <a:p>
             <a:r>
-              <a:t>1. На основі вимог замовника EXP-01..EXP-06 ми розробили деталізований беклог із 12 User Stories.</a:t>
-            </a:r>
-          </a:p>
-          <a:p>
-            <a:r>
-              <a:t>2. Усі історії написані за стандартом Connextra від імені реальних користувачів: студента, викладача, менеджера та адміна.</a:t>
-            </a:r>
-          </a:p>
-          <a:p>
-            <a:r>
-              <a:t>3. Особливу увагу ми приділили усуненню неоднозначностей. Наприклад, правило нарахування штрафів за прострочені дедлайни формалізовано через математичну функцію стелі, що виключає різночитання при розробці та тестуванні.</a:t>
-            </a:r>
-          </a:p>
-          <a:p>
-            <a:r>
-              <a:t>4. Матриця трасованості підтверджує 100% покриття всіх очікувань замовника.</a:t>
+              <a:t>1. Беклог містить 12 деталізованих User Stories від живих користувачів.</a:t>
+            </a:r>
+          </a:p>
+          <a:p>
+            <a:r>
+              <a:t>2. Для усунення розбіжностей формула штрафу за дедлайн уніфікована через математичну функцію стелі ⌈Δt⌉.</a:t>
+            </a:r>
+          </a:p>
+          <a:p>
+            <a:r>
+              <a:t>3. Кожна вимога замовника EXP-01..06 трасована на відповідні US.</a:t>
             </a:r>
           </a:p>
         </p:txBody>
@@ -1070,17 +1065,17 @@
           </a:p>
           <a:p>
             <a:r>
-              <a:t>1. Ми вели чесний та прозорий облік часу в tasks.md. Сумарні витрати склали 31.1 людино-годину при плані 24.5 год.</a:t>
-            </a:r>
-          </a:p>
-          <a:p>
-            <a:r>
-              <a:t>2. У середньому на кожного учасника припало 10.4 години, що ідеально вкладається в академічний норматив (8–12 год).</a:t>
-            </a:r>
-          </a:p>
-          <a:p>
-            <a:r>
-              <a:t>3. Перевитрата часу була спричинена виключно інженерними завданнями: ручним доопрацюванням BPMN XML для повної сумісності з bpmn.io та деталізацією критеріїв прийняття User Stories.</a:t>
+              <a:t>1. Фактичні витрати склали 31.1 год (у середньому 10.4 год на людину при нормі 8–12 год).</a:t>
+            </a:r>
+          </a:p>
+          <a:p>
+            <a:r>
+              <a:t>2. Перевитрата часу (+6.6 год) зумовлена виправленням тонких інженерних нюансів у BPMN XML та формалізацією Acceptance Criteria.</a:t>
+            </a:r>
+          </a:p>
+          <a:p>
+            <a:r>
+              <a:t>3. Тайм-трекінг вівся щоденно з 16 по 25 вересня.</a:t>
             </a:r>
           </a:p>
         </p:txBody>
@@ -1160,17 +1155,17 @@
           </a:p>
           <a:p>
             <a:r>
-              <a:t>1. Ретроспектива допомогла виявити як наші сильні сторони, так і зони росту.</a:t>
-            </a:r>
-          </a:p>
-          <a:p>
-            <a:r>
-              <a:t>2. У форматі Start/Stop/Continue ми вирішили проводити перехресне рецензування мінімум за 2 дні до дедлайну, щоб уникати авралів перед здачею.</a:t>
-            </a:r>
-          </a:p>
-          <a:p>
-            <a:r>
-              <a:t>3. На Спринт 2 (Тест-дизайн) ми входимо з чітким планом покращення процесів.</a:t>
+              <a:t>1. У межах ретроспективи Спринта 1 ми зафіксували уроки в форматі Start/Stop/Continue.</a:t>
+            </a:r>
+          </a:p>
+          <a:p>
+            <a:r>
+              <a:t>2. Головні висновки: закладати 20% резерву часу на доопрацювання та проводити рев'ю завчасно.</a:t>
+            </a:r>
+          </a:p>
+          <a:p>
+            <a:r>
+              <a:t>3. Усі рішення мають закріплених відповідальних осіб.</a:t>
             </a:r>
           </a:p>
         </p:txBody>
@@ -1255,12 +1250,7 @@
           </a:p>
           <a:p>
             <a:r>
-              <a:t>2. Команда повністю готова до переходу на Спринт 2 (Тест-дизайн та розробка тест-плану).</a:t>
-            </a:r>
-          </a:p>
-          <a:p>
-            <a:r>
-              <a:t>3. Дякуємо за увагу, готові до запитань комісії!</a:t>
+              <a:t>2. Дякуємо за увагу, готові до запитань комісії!</a:t>
             </a:r>
           </a:p>
         </p:txBody>
@@ -4690,7 +4680,7 @@
         <p:spPr>
           <a:xfrm>
             <a:off x="731520" y="1463040"/>
-            <a:ext cx="3328416" cy="4846320"/>
+            <a:ext cx="5175504" cy="4846320"/>
           </a:xfrm>
           <a:prstGeom prst="roundRect">
             <a:avLst/>
@@ -4735,7 +4725,7 @@
         <p:spPr>
           <a:xfrm>
             <a:off x="914400" y="1645920"/>
-            <a:ext cx="2962656" cy="4480560"/>
+            <a:ext cx="4809744" cy="4480560"/>
           </a:xfrm>
           <a:prstGeom prst="rect">
             <a:avLst/>
@@ -4749,20 +4739,20 @@
           <a:lstStyle/>
           <a:p>
             <a:pPr>
-              <a:defRPr sz="1400" b="1">
+              <a:defRPr sz="1300" b="1">
                 <a:solidFill>
                   <a:srgbClr val="2563EB"/>
                 </a:solidFill>
               </a:defRPr>
             </a:pPr>
             <a:r>
-              <a:t>🎯 ПРОФІЛЬ ПРОДУКТУ</a:t>
+              <a:t>🎯 ПРОФІЛЬ ПРОДУКТУ ТА ПРАВИЛА ВЗАЄМОДІЇ</a:t>
             </a:r>
           </a:p>
           <a:p>
             <a:pPr>
               <a:spcBef>
-                <a:spcPts val="800"/>
+                <a:spcPts val="600"/>
               </a:spcBef>
               <a:defRPr sz="1100">
                 <a:solidFill>
@@ -4771,13 +4761,13 @@
               </a:defRPr>
             </a:pPr>
             <a:r>
-              <a:t>Тип системи: LMS (Learning Management System) для ЗВО та корпоративного навчання.</a:t>
+              <a:t>• Продукт: LMS «ЕдуПортал» (система дистанційного навчання для ЗВО).</a:t>
             </a:r>
           </a:p>
           <a:p>
             <a:pPr>
               <a:spcBef>
-                <a:spcPts val="800"/>
+                <a:spcPts val="600"/>
               </a:spcBef>
               <a:defRPr sz="1100">
                 <a:solidFill>
@@ -4786,13 +4776,13 @@
               </a:defRPr>
             </a:pPr>
             <a:r>
-              <a:t>Цільова аудиторія: Студенти, викладачі, менеджери курсів, системні адміністратори.</a:t>
+              <a:t>• Цільові ролі: Студент, Викладач, Менеджер курсів, Системний адміністратор.</a:t>
             </a:r>
           </a:p>
           <a:p>
             <a:pPr>
               <a:spcBef>
-                <a:spcPts val="800"/>
+                <a:spcPts val="600"/>
               </a:spcBef>
               <a:defRPr sz="1100">
                 <a:solidFill>
@@ -4801,13 +4791,13 @@
               </a:defRPr>
             </a:pPr>
             <a:r>
-              <a:t>Ключова цінність: Автоматизація контролю знань (QuizScorer), інтерактивна здача робіт, прозорий облік дедлайнів.</a:t>
+              <a:t>• Демо-середовище: Розгорнуто 4 рольові акаунти (admin, manager, teacher, student).</a:t>
             </a:r>
           </a:p>
           <a:p>
             <a:pPr>
               <a:spcBef>
-                <a:spcPts val="800"/>
+                <a:spcPts val="600"/>
               </a:spcBef>
               <a:defRPr sz="1100">
                 <a:solidFill>
@@ -4816,13 +4806,13 @@
               </a:defRPr>
             </a:pPr>
             <a:r>
-              <a:t>Стек технологій: PostgreSQL, Backend API, Web/Mobile SPA.</a:t>
+              <a:t>• Командні стендапи: Щоденно до 11:00 в асинхронному форматі в робочому чаті.</a:t>
             </a:r>
           </a:p>
           <a:p>
             <a:pPr>
               <a:spcBef>
-                <a:spcPts val="800"/>
+                <a:spcPts val="600"/>
               </a:spcBef>
               <a:defRPr sz="1100">
                 <a:solidFill>
@@ -4831,7 +4821,22 @@
               </a:defRPr>
             </a:pPr>
             <a:r>
-              <a:t>Демо-середовище: Розгорнуто 4 рольові тестові акаунти (admin, manager, teacher, student).</a:t>
+              <a:t>• Peer Review: 100% артефактів проходять взаємне рецензування перед злиттям.</a:t>
+            </a:r>
+          </a:p>
+          <a:p>
+            <a:pPr>
+              <a:spcBef>
+                <a:spcPts val="600"/>
+              </a:spcBef>
+              <a:defRPr sz="1100">
+                <a:solidFill>
+                  <a:srgbClr val="1E293B"/>
+                </a:solidFill>
+              </a:defRPr>
+            </a:pPr>
+            <a:r>
+              <a:t>• Definition of Done: BPMN валідовано у bpmn.io, повна трасованість вимог EXP ↔ US.</a:t>
             </a:r>
           </a:p>
         </p:txBody>
@@ -4844,8 +4849,8 @@
         </p:nvSpPr>
         <p:spPr>
           <a:xfrm>
-            <a:off x="4425696" y="1463040"/>
-            <a:ext cx="3328416" cy="4846320"/>
+            <a:off x="6272784" y="1463040"/>
+            <a:ext cx="5175504" cy="4846320"/>
           </a:xfrm>
           <a:prstGeom prst="roundRect">
             <a:avLst/>
@@ -4889,8 +4894,8 @@
         </p:nvSpPr>
         <p:spPr>
           <a:xfrm>
-            <a:off x="4608576" y="1645920"/>
-            <a:ext cx="2962656" cy="4480560"/>
+            <a:off x="6455664" y="1645920"/>
+            <a:ext cx="4809744" cy="4480560"/>
           </a:xfrm>
           <a:prstGeom prst="rect">
             <a:avLst/>
@@ -4904,154 +4909,29 @@
           <a:lstStyle/>
           <a:p>
             <a:pPr>
-              <a:defRPr sz="1400" b="1">
-                <a:solidFill>
-                  <a:srgbClr val="0D9488"/>
-                </a:solidFill>
-              </a:defRPr>
-            </a:pPr>
-            <a:r>
-              <a:t>🤝 КОМАНДНИЙ СТАТУТ</a:t>
+              <a:defRPr sz="1300" b="1">
+                <a:solidFill>
+                  <a:srgbClr val="D97706"/>
+                </a:solidFill>
+              </a:defRPr>
+            </a:pPr>
+            <a:r>
+              <a:t>🔄 МАТРИЦЯ РОТАЦІЇ РОЛЕЙ НА СЕМЕСТР (§5.2)</a:t>
             </a:r>
           </a:p>
           <a:p>
             <a:pPr>
               <a:spcBef>
-                <a:spcPts val="800"/>
+                <a:spcPts val="400"/>
               </a:spcBef>
-              <a:defRPr sz="1100">
-                <a:solidFill>
-                  <a:srgbClr val="1E293B"/>
-                </a:solidFill>
-              </a:defRPr>
-            </a:pPr>
-            <a:r>
-              <a:t>Правила взаємодії: Щоденні асинхронні стендапи до 11:00 у Telegram, спільний репозиторій на GitHub.</a:t>
-            </a:r>
-          </a:p>
-          <a:p>
-            <a:pPr>
-              <a:spcBef>
-                <a:spcPts val="800"/>
-              </a:spcBef>
-              <a:defRPr sz="1100">
-                <a:solidFill>
-                  <a:srgbClr val="1E293B"/>
-                </a:solidFill>
-              </a:defRPr>
-            </a:pPr>
-            <a:r>
-              <a:t>Контроль коду й доків: Обов'язкове перехресне рецензування (Peer Review) перед злиттям у main.</a:t>
-            </a:r>
-          </a:p>
-          <a:p>
-            <a:pPr>
-              <a:spcBef>
-                <a:spcPts val="800"/>
-              </a:spcBef>
-              <a:defRPr sz="1100">
-                <a:solidFill>
-                  <a:srgbClr val="1E293B"/>
-                </a:solidFill>
-              </a:defRPr>
-            </a:pPr>
-            <a:r>
-              <a:t>Нормативне навантаження: Розподіл 8–12 год на особу за спринт.</a:t>
-            </a:r>
-          </a:p>
-          <a:p>
-            <a:pPr>
-              <a:spcBef>
-                <a:spcPts val="800"/>
-              </a:spcBef>
-              <a:defRPr sz="1100">
-                <a:solidFill>
-                  <a:srgbClr val="1E293B"/>
-                </a:solidFill>
-              </a:defRPr>
-            </a:pPr>
-            <a:r>
-              <a:t>Definition of Done: Артефакт прийнятий рецензентом, BPMN валідовано у bpmn.io, 100% трасованість вимог.</a:t>
-            </a:r>
-          </a:p>
-        </p:txBody>
-      </p:sp>
-      <p:sp>
-        <p:nvSpPr>
-          <p:cNvPr id="10" name="Rounded Rectangle 9"/>
-          <p:cNvSpPr/>
-          <p:nvPr/>
-        </p:nvSpPr>
-        <p:spPr>
-          <a:xfrm>
-            <a:off x="8119872" y="1463040"/>
-            <a:ext cx="3328416" cy="4846320"/>
-          </a:xfrm>
-          <a:prstGeom prst="roundRect">
-            <a:avLst/>
-          </a:prstGeom>
-          <a:solidFill>
-            <a:srgbClr val="FFFFFF"/>
-          </a:solidFill>
-          <a:ln w="19050">
-            <a:solidFill>
-              <a:srgbClr val="E2E8F0"/>
-            </a:solidFill>
-          </a:ln>
-        </p:spPr>
-        <p:style>
-          <a:lnRef idx="1">
-            <a:schemeClr val="accent1"/>
-          </a:lnRef>
-          <a:fillRef idx="3">
-            <a:schemeClr val="accent1"/>
-          </a:fillRef>
-          <a:effectRef idx="2">
-            <a:schemeClr val="accent1"/>
-          </a:effectRef>
-          <a:fontRef idx="minor">
-            <a:schemeClr val="lt1"/>
-          </a:fontRef>
-        </p:style>
-        <p:txBody>
-          <a:bodyPr rtlCol="0" anchor="ctr"/>
-          <a:lstStyle/>
-          <a:p>
-            <a:pPr algn="ctr"/>
-          </a:p>
-        </p:txBody>
-      </p:sp>
-      <p:sp>
-        <p:nvSpPr>
-          <p:cNvPr id="11" name="TextBox 10"/>
-          <p:cNvSpPr txBox="1"/>
-          <p:nvPr/>
-        </p:nvSpPr>
-        <p:spPr>
-          <a:xfrm>
-            <a:off x="8302752" y="1645920"/>
-            <a:ext cx="2962656" cy="4480560"/>
-          </a:xfrm>
-          <a:prstGeom prst="rect">
-            <a:avLst/>
-          </a:prstGeom>
-          <a:noFill/>
-        </p:spPr>
-        <p:txBody>
-          <a:bodyPr wrap="square">
-            <a:spAutoFit/>
-          </a:bodyPr>
-          <a:lstStyle/>
-          <a:p>
-            <a:pPr>
-              <a:defRPr sz="1400" b="1">
-                <a:solidFill>
-                  <a:srgbClr val="D97706"/>
-                </a:solidFill>
-              </a:defRPr>
-            </a:pPr>
-            <a:r>
-              <a:t>🔄 МАТРИЦЯ РОТАЦІЇ РОЛЕЙ</a:t>
+              <a:defRPr sz="1050">
+                <a:solidFill>
+                  <a:srgbClr val="64748B"/>
+                </a:solidFill>
+              </a:defRPr>
+            </a:pPr>
+            <a:r>
+              <a:t>Кожен учасник змінює інженерну роль у кожному новому спринті:</a:t>
             </a:r>
           </a:p>
           <a:p>
@@ -5066,11 +4946,11 @@
               </a:defRPr>
             </a:pPr>
             <a:r>
-              <a:t>Спринт 1 (Вимоги):</a:t>
+              <a:t>📌 Спринт 1 (Вимоги):</a:t>
             </a:r>
             <a:br/>
             <a:r>
-              <a:t>Denchik (КТ+СМ) | 5ani0chek (ІТ) | Vov4ik (ТА)</a:t>
+              <a:t>   Denchik (КТ+СМ) → 5ani0chek (ІТ) → Vov4ik (ТА)</a:t>
             </a:r>
           </a:p>
           <a:p>
@@ -5085,11 +4965,11 @@
               </a:defRPr>
             </a:pPr>
             <a:r>
-              <a:t>Спринт 2 (Тест-дизайн):</a:t>
+              <a:t>📌 Спринт 2 (Стратегія):</a:t>
             </a:r>
             <a:br/>
             <a:r>
-              <a:t>5ani0chek (КТ+СМ) | Vov4ik (ІТ) | Denchik (ТА)</a:t>
+              <a:t>   5ani0chek (КТ+СМ) → Vov4ik (ІТ) → Denchik (ТА)</a:t>
             </a:r>
           </a:p>
           <a:p>
@@ -5104,11 +4984,11 @@
               </a:defRPr>
             </a:pPr>
             <a:r>
-              <a:t>Спринт 3 (Виконання):</a:t>
+              <a:t>📌 Спринт 3 (Тест-кейси):</a:t>
             </a:r>
             <a:br/>
             <a:r>
-              <a:t>Vov4ik (КТ+СМ) | Denchik (ІТ) | 5ani0chek (ТА)</a:t>
+              <a:t>   Vov4ik (КТ+СМ) → Denchik (ІТ) → 5ani0chek (ТА)</a:t>
             </a:r>
           </a:p>
           <a:p>
@@ -5123,11 +5003,11 @@
               </a:defRPr>
             </a:pPr>
             <a:r>
-              <a:t>Спринт 4 (Автоматизація):</a:t>
+              <a:t>📌 Спринт 4 (Автоматизація):</a:t>
             </a:r>
             <a:br/>
             <a:r>
-              <a:t>Denchik (КТ+СМ) | 5ani0chek (ІТ) | Vov4ik (ТА)</a:t>
+              <a:t>   Denchik (КТ+СМ) → 5ani0chek (ІТ) → Vov4ik (ТА)</a:t>
             </a:r>
           </a:p>
           <a:p>
@@ -5142,11 +5022,11 @@
               </a:defRPr>
             </a:pPr>
             <a:r>
-              <a:t>Спринт 5 (Підсумки):</a:t>
+              <a:t>📌 Спринт 5 (Підсумки):</a:t>
             </a:r>
             <a:br/>
             <a:r>
-              <a:t>5ani0chek (КТ+СМ) | Vov4ik (ІТ) | Denchik (ТА)</a:t>
+              <a:t>   5ani0chek (КТ+СМ) → Vov4ik (ІТ) → Denchik (ТА)</a:t>
             </a:r>
           </a:p>
         </p:txBody>
@@ -8261,7 +8141,7 @@
               </a:defRPr>
             </a:pPr>
             <a:r>
-              <a:t>Ретроспектива Спринта 1 та рішення на Спринт 2 (retro.md)</a:t>
+              <a:t>Ретроспектива Спринта 1: аналіз та рішення на майбутнє (retro.md)</a:t>
             </a:r>
           </a:p>
         </p:txBody>
@@ -8384,7 +8264,7 @@
               </a:defRPr>
             </a:pPr>
             <a:r>
-              <a:t>🟢 START (Почати)</a:t>
+              <a:t>🟢 START (Почати робити)</a:t>
             </a:r>
           </a:p>
           <a:p>
@@ -8509,7 +8389,7 @@
               </a:defRPr>
             </a:pPr>
             <a:r>
-              <a:t>🔴 STOP (Припинити)</a:t>
+              <a:t>🔴 STOP (Припинити робити)</a:t>
             </a:r>
           </a:p>
           <a:p>
@@ -8634,7 +8514,7 @@
               </a:defRPr>
             </a:pPr>
             <a:r>
-              <a:t>🔵 CONTINUE &amp; ПЛАН</a:t>
+              <a:t>🔵 ВПРОВАДЖЕННЯ РІШЕНЬ</a:t>
             </a:r>
           </a:p>
           <a:p>
@@ -8649,7 +8529,7 @@
               </a:defRPr>
             </a:pPr>
             <a:r>
-              <a:t>• Детально розписувати критерії прийняття та граничні випадки.</a:t>
+              <a:t>• Проводити взаємне рецензування мінімум за 2 дні до дедлайну (відп. Vov4ik).</a:t>
             </a:r>
           </a:p>
           <a:p>
@@ -8664,7 +8544,7 @@
               </a:defRPr>
             </a:pPr>
             <a:r>
-              <a:t>• Підтримувати взаємодопомогу та високу інженерну точність.</a:t>
+              <a:t>• Обов'язково валідувати схеми у bpmn.io до здачі (відп. 5ani0chek).</a:t>
             </a:r>
           </a:p>
           <a:p>
@@ -8679,7 +8559,7 @@
               </a:defRPr>
             </a:pPr>
             <a:r>
-              <a:t>• Рішення на Спринт 2: проводити рев'ю за 2 дні до здачі та закладати +20% буферного часу.</a:t>
+              <a:t>• Щоденно актуалізувати tasks.md та закладати +20% буферного часу (відп. Denchik).</a:t>
             </a:r>
           </a:p>
         </p:txBody>
@@ -8793,7 +8673,7 @@
               </a:defRPr>
             </a:pPr>
             <a:r>
-              <a:t>Команда EduGuard готова до Спринта 2!</a:t>
+              <a:t>Команда EduGuard успішно виконала Спринт 1!</a:t>
             </a:r>
           </a:p>
           <a:p>
@@ -8853,7 +8733,7 @@
               </a:defRPr>
             </a:pPr>
             <a:r>
-              <a:t>✓  Чесний щоденний тайм-трекінг та детальний протокол ретроспективи.</a:t>
+              <a:t>✓  Чесний щоденний тайм-трекінг (31.1 год) та детальний протокол ретроспективи.</a:t>
             </a:r>
           </a:p>
           <a:p>

</xml_diff>